<commit_message>
chore(pygeek): rev7 — Conclusion 각주 삭제, Thank You 에 연락처 추가
발표자 직접 수정분.
- Conclusion(13쪽): 한계·향후과제 회색 각주 제거 → 꼭지 4개만 남음
- Thank You(15쪽): "Contact to me: <교내 메일>" 한 줄 추가

Co-Authored-By: Claude Opus 5 <noreply@anthropic.com>
</commit_message>
<xml_diff>
--- a/docs/reference/PyGeek2026_발표_윤준하_rev7.pptx
+++ b/docs/reference/PyGeek2026_발표_윤준하_rev7.pptx
@@ -4455,7 +4455,7 @@
     <mc:Choice Requires="p14">
       <p:transition/>
     </mc:Choice>
-    <mc:Fallback xmlns:dsp="http://schemas.microsoft.com/office/drawing/2008/diagram" xmlns:dgm="http://schemas.openxmlformats.org/drawingml/2006/diagram" xmlns:c="http://schemas.openxmlformats.org/drawingml/2006/chart" xmlns="">
+    <mc:Fallback xmlns="" xmlns:c="http://schemas.openxmlformats.org/drawingml/2006/chart" xmlns:dgm="http://schemas.openxmlformats.org/drawingml/2006/diagram" xmlns:dsp="http://schemas.microsoft.com/office/drawing/2008/diagram">
       <p:transition/>
     </mc:Fallback>
   </mc:AlternateContent>
@@ -6561,7 +6561,7 @@
               </a:lnSpc>
             </a:pPr>
             <a:r>
-              <a:rPr lang="en-US" altLang="en-US" sz="1600" b="0">
+              <a:rPr lang="en-US" altLang="en-US" sz="1600" b="0" dirty="0">
                 <a:solidFill>
                   <a:srgbClr val="1A1A1A"/>
                 </a:solidFill>
@@ -6582,7 +6582,7 @@
               </a:spcBef>
             </a:pPr>
             <a:r>
-              <a:rPr lang="en-US" altLang="en-US" sz="1600" b="0">
+              <a:rPr lang="en-US" altLang="en-US" sz="1600" b="0" dirty="0">
                 <a:solidFill>
                   <a:srgbClr val="1A1A1A"/>
                 </a:solidFill>
@@ -6591,111 +6591,6 @@
                 <a:cs typeface="Arial"/>
               </a:rPr>
               <a:t>·   If the query path must stay inside, confirm the model size limit before migrating</a:t>
-            </a:r>
-          </a:p>
-        </p:txBody>
-      </p:sp>
-      <p:sp>
-        <p:nvSpPr>
-          <p:cNvPr id="33" name="TextBox 32"/>
-          <p:cNvSpPr txBox="1"/>
-          <p:nvPr/>
-        </p:nvSpPr>
-        <p:spPr>
-          <a:xfrm>
-            <a:off x="713232" y="4425696"/>
-            <a:ext cx="10323576" cy="1005840"/>
-          </a:xfrm>
-          <a:prstGeom prst="rect">
-            <a:avLst/>
-          </a:prstGeom>
-          <a:noFill/>
-        </p:spPr>
-        <p:txBody>
-          <a:bodyPr wrap="square" lIns="0" tIns="0" rIns="0" bIns="0" anchor="t">
-            <a:noAutofit/>
-          </a:bodyPr>
-          <a:lstStyle/>
-          <a:p>
-            <a:pPr>
-              <a:lnSpc>
-                <a:spcPct val="125000"/>
-              </a:lnSpc>
-            </a:pPr>
-            <a:r>
-              <a:rPr lang="en-US" altLang="en-US" sz="1300" b="1">
-                <a:solidFill>
-                  <a:srgbClr val="6D6D6D"/>
-                </a:solidFill>
-                <a:latin typeface="Arial"/>
-                <a:ea typeface="Arial"/>
-                <a:cs typeface="Arial"/>
-              </a:rPr>
-              <a:t>Limitations — </a:t>
-            </a:r>
-            <a:r>
-              <a:rPr lang="en-US" altLang="en-US" sz="1300" b="0">
-                <a:solidFill>
-                  <a:srgbClr val="6D6D6D"/>
-                </a:solidFill>
-                <a:latin typeface="Arial"/>
-                <a:ea typeface="Arial"/>
-                <a:cs typeface="Arial"/>
-              </a:rPr>
-              <a:t>one Korean corpus of 1,347 chunks, relevance scored without human assessors, an entry-level instance.</a:t>
-            </a:r>
-          </a:p>
-          <a:p>
-            <a:pPr>
-              <a:lnSpc>
-                <a:spcPct val="125000"/>
-              </a:lnSpc>
-              <a:spcBef>
-                <a:spcPts val="600"/>
-              </a:spcBef>
-            </a:pPr>
-            <a:r>
-              <a:rPr lang="en-US" altLang="en-US" sz="1300" b="0">
-                <a:solidFill>
-                  <a:srgbClr val="6D6D6D"/>
-                </a:solidFill>
-                <a:latin typeface="Arial"/>
-                <a:ea typeface="Arial"/>
-                <a:cs typeface="Arial"/>
-              </a:rPr>
-              <a:t>Placement and model size are coupled by construction, and the store result does not establish equivalence.</a:t>
-            </a:r>
-          </a:p>
-          <a:p>
-            <a:pPr>
-              <a:lnSpc>
-                <a:spcPct val="125000"/>
-              </a:lnSpc>
-              <a:spcBef>
-                <a:spcPts val="600"/>
-              </a:spcBef>
-            </a:pPr>
-            <a:r>
-              <a:rPr lang="en-US" altLang="en-US" sz="1300" b="1">
-                <a:solidFill>
-                  <a:srgbClr val="6D6D6D"/>
-                </a:solidFill>
-                <a:latin typeface="Arial"/>
-                <a:ea typeface="Arial"/>
-                <a:cs typeface="Arial"/>
-              </a:rPr>
-              <a:t>Future work — </a:t>
-            </a:r>
-            <a:r>
-              <a:rPr lang="en-US" altLang="en-US" sz="1300" b="0">
-                <a:solidFill>
-                  <a:srgbClr val="6D6D6D"/>
-                </a:solidFill>
-                <a:latin typeface="Arial"/>
-                <a:ea typeface="Arial"/>
-                <a:cs typeface="Arial"/>
-              </a:rPr>
-              <a:t>a fourth condition running the smaller model outside the database.</a:t>
             </a:r>
           </a:p>
         </p:txBody>
@@ -7406,7 +7301,7 @@
           <a:p>
             <a:pPr algn="ctr"/>
             <a:r>
-              <a:rPr lang="en-US" altLang="en-US" sz="5400" b="1" i="0">
+              <a:rPr lang="en-US" altLang="en-US" sz="5400" b="1" i="0" dirty="0">
                 <a:solidFill>
                   <a:srgbClr val="1A1A1A"/>
                 </a:solidFill>
@@ -7416,6 +7311,39 @@
               </a:rPr>
               <a:t>Thank You</a:t>
             </a:r>
+          </a:p>
+          <a:p>
+            <a:pPr algn="ctr"/>
+            <a:endParaRPr lang="en-US" altLang="en-US" sz="5400" b="1" dirty="0">
+              <a:solidFill>
+                <a:srgbClr val="1A1A1A"/>
+              </a:solidFill>
+              <a:latin typeface="Arial"/>
+              <a:ea typeface="Arial"/>
+              <a:cs typeface="Arial"/>
+            </a:endParaRPr>
+          </a:p>
+          <a:p>
+            <a:pPr algn="ctr"/>
+            <a:r>
+              <a:rPr lang="en-US" altLang="en-US" sz="2000" b="1" dirty="0">
+                <a:solidFill>
+                  <a:srgbClr val="1A1A1A"/>
+                </a:solidFill>
+                <a:latin typeface="Arial"/>
+                <a:ea typeface="Arial"/>
+                <a:cs typeface="Arial"/>
+              </a:rPr>
+              <a:t>Contact to me: wnsgk111400@sungkyul.ac.kr</a:t>
+            </a:r>
+            <a:endParaRPr lang="en-US" altLang="en-US" sz="2000" b="1" i="0" dirty="0">
+              <a:solidFill>
+                <a:srgbClr val="1A1A1A"/>
+              </a:solidFill>
+              <a:latin typeface="Arial"/>
+              <a:ea typeface="Arial"/>
+              <a:cs typeface="Arial"/>
+            </a:endParaRPr>
           </a:p>
         </p:txBody>
       </p:sp>

</xml_diff>